<commit_message>
Add hands-on lab for Saga Messaging Pattern with detailed implementation steps and service coordination
</commit_message>
<xml_diff>
--- a/slides/01 - Welcome.pptx
+++ b/slides/01 - Welcome.pptx
@@ -5,16 +5,18 @@
     <p:sldMasterId id="2147483648" r:id="rId1"/>
   </p:sldMasterIdLst>
   <p:notesMasterIdLst>
-    <p:notesMasterId r:id="rId6"/>
+    <p:notesMasterId r:id="rId8"/>
   </p:notesMasterIdLst>
   <p:handoutMasterIdLst>
-    <p:handoutMasterId r:id="rId7"/>
+    <p:handoutMasterId r:id="rId9"/>
   </p:handoutMasterIdLst>
   <p:sldIdLst>
     <p:sldId id="264" r:id="rId2"/>
     <p:sldId id="265" r:id="rId3"/>
-    <p:sldId id="266" r:id="rId4"/>
-    <p:sldId id="267" r:id="rId5"/>
+    <p:sldId id="268" r:id="rId4"/>
+    <p:sldId id="269" r:id="rId5"/>
+    <p:sldId id="266" r:id="rId6"/>
+    <p:sldId id="267" r:id="rId7"/>
   </p:sldIdLst>
   <p:sldSz cx="12192000" cy="6858000"/>
   <p:notesSz cx="6858000" cy="9144000"/>
@@ -215,7 +217,7 @@
           <a:p>
             <a:fld id="{1364EA34-5607-42FC-A5EC-B3EB34B980C7}" type="datetimeFigureOut">
               <a:rPr lang="en-US" smtClean="0"/>
-              <a:t>8/5/2025</a:t>
+              <a:t>8/6/2025</a:t>
             </a:fld>
             <a:endParaRPr lang="en-US"/>
           </a:p>
@@ -392,7 +394,7 @@
           <a:p>
             <a:fld id="{BFB21A4E-9E2A-47D2-8D53-809F7F857FEB}" type="datetimeFigureOut">
               <a:rPr lang="en-US" smtClean="0"/>
-              <a:t>8/5/2025</a:t>
+              <a:t>8/6/2025</a:t>
             </a:fld>
             <a:endParaRPr lang="en-US"/>
           </a:p>
@@ -3111,6 +3113,36 @@
           <a:noFill/>
         </p:spPr>
       </p:pic>
+      <p:pic>
+        <p:nvPicPr>
+          <p:cNvPr id="4" name="Picture 3">
+            <a:extLst>
+              <a:ext uri="{FF2B5EF4-FFF2-40B4-BE49-F238E27FC236}">
+                <a16:creationId xmlns:a16="http://schemas.microsoft.com/office/drawing/2014/main" id="{A67CEF77-724D-D5AB-6386-A4A6FD9B4428}"/>
+              </a:ext>
+            </a:extLst>
+          </p:cNvPr>
+          <p:cNvPicPr>
+            <a:picLocks noChangeAspect="1"/>
+          </p:cNvPicPr>
+          <p:nvPr/>
+        </p:nvPicPr>
+        <p:blipFill>
+          <a:blip r:embed="rId3"/>
+          <a:stretch>
+            <a:fillRect/>
+          </a:stretch>
+        </p:blipFill>
+        <p:spPr>
+          <a:xfrm>
+            <a:off x="8868102" y="3497315"/>
+            <a:ext cx="3138981" cy="3138981"/>
+          </a:xfrm>
+          <a:prstGeom prst="rect">
+            <a:avLst/>
+          </a:prstGeom>
+        </p:spPr>
+      </p:pic>
     </p:spTree>
     <p:extLst>
       <p:ext uri="{BB962C8B-B14F-4D97-AF65-F5344CB8AC3E}">
@@ -3718,6 +3750,759 @@
   <p:cSld>
     <p:spTree>
       <p:nvGrpSpPr>
+        <p:cNvPr id="1" name="">
+          <a:extLst>
+            <a:ext uri="{FF2B5EF4-FFF2-40B4-BE49-F238E27FC236}">
+              <a16:creationId xmlns:a16="http://schemas.microsoft.com/office/drawing/2014/main" id="{DD94416B-F15A-EED3-7BC7-6C12D7382084}"/>
+            </a:ext>
+          </a:extLst>
+        </p:cNvPr>
+        <p:cNvGrpSpPr/>
+        <p:nvPr/>
+      </p:nvGrpSpPr>
+      <p:grpSpPr>
+        <a:xfrm>
+          <a:off x="0" y="0"/>
+          <a:ext cx="0" cy="0"/>
+          <a:chOff x="0" y="0"/>
+          <a:chExt cx="0" cy="0"/>
+        </a:xfrm>
+      </p:grpSpPr>
+      <p:sp>
+        <p:nvSpPr>
+          <p:cNvPr id="2" name="Title 1">
+            <a:extLst>
+              <a:ext uri="{FF2B5EF4-FFF2-40B4-BE49-F238E27FC236}">
+                <a16:creationId xmlns:a16="http://schemas.microsoft.com/office/drawing/2014/main" id="{2F0BB03E-0B4C-4341-866E-D337DAB8C016}"/>
+              </a:ext>
+            </a:extLst>
+          </p:cNvPr>
+          <p:cNvSpPr>
+            <a:spLocks noGrp="1"/>
+          </p:cNvSpPr>
+          <p:nvPr>
+            <p:ph type="title"/>
+          </p:nvPr>
+        </p:nvSpPr>
+        <p:spPr/>
+        <p:txBody>
+          <a:bodyPr/>
+          <a:lstStyle/>
+          <a:p>
+            <a:r>
+              <a:rPr lang="en-US" dirty="0"/>
+              <a:t>Who is Sean Whitesell?</a:t>
+            </a:r>
+          </a:p>
+        </p:txBody>
+      </p:sp>
+      <p:pic>
+        <p:nvPicPr>
+          <p:cNvPr id="10" name="Picture 9">
+            <a:extLst>
+              <a:ext uri="{FF2B5EF4-FFF2-40B4-BE49-F238E27FC236}">
+                <a16:creationId xmlns:a16="http://schemas.microsoft.com/office/drawing/2014/main" id="{E76E92CF-B8BF-395A-31C5-70A43D4591B9}"/>
+              </a:ext>
+            </a:extLst>
+          </p:cNvPr>
+          <p:cNvPicPr>
+            <a:picLocks noChangeAspect="1"/>
+          </p:cNvPicPr>
+          <p:nvPr/>
+        </p:nvPicPr>
+        <p:blipFill>
+          <a:blip r:embed="rId2" cstate="email">
+            <a:extLst>
+              <a:ext uri="{28A0092B-C50C-407E-A947-70E740481C1C}">
+                <a14:useLocalDpi xmlns:a14="http://schemas.microsoft.com/office/drawing/2010/main"/>
+              </a:ext>
+            </a:extLst>
+          </a:blip>
+          <a:stretch>
+            <a:fillRect/>
+          </a:stretch>
+        </p:blipFill>
+        <p:spPr>
+          <a:xfrm>
+            <a:off x="472151" y="5171221"/>
+            <a:ext cx="2289053" cy="923546"/>
+          </a:xfrm>
+          <a:prstGeom prst="rect">
+            <a:avLst/>
+          </a:prstGeom>
+        </p:spPr>
+      </p:pic>
+      <p:pic>
+        <p:nvPicPr>
+          <p:cNvPr id="1026" name="Picture 2" descr="Profile photo of Sean Whitesell">
+            <a:extLst>
+              <a:ext uri="{FF2B5EF4-FFF2-40B4-BE49-F238E27FC236}">
+                <a16:creationId xmlns:a16="http://schemas.microsoft.com/office/drawing/2014/main" id="{1644EFA3-4573-11E4-8655-EC6D91BD42BC}"/>
+              </a:ext>
+            </a:extLst>
+          </p:cNvPr>
+          <p:cNvPicPr>
+            <a:picLocks noChangeAspect="1" noChangeArrowheads="1"/>
+          </p:cNvPicPr>
+          <p:nvPr/>
+        </p:nvPicPr>
+        <p:blipFill rotWithShape="1">
+          <a:blip r:embed="rId3">
+            <a:extLst>
+              <a:ext uri="{28A0092B-C50C-407E-A947-70E740481C1C}">
+                <a14:useLocalDpi xmlns:a14="http://schemas.microsoft.com/office/drawing/2010/main" val="0"/>
+              </a:ext>
+            </a:extLst>
+          </a:blip>
+          <a:srcRect l="19502" r="19502"/>
+          <a:stretch>
+            <a:fillRect/>
+          </a:stretch>
+        </p:blipFill>
+        <p:spPr bwMode="auto">
+          <a:xfrm>
+            <a:off x="8008882" y="0"/>
+            <a:ext cx="4183117" cy="6858000"/>
+          </a:xfrm>
+          <a:prstGeom prst="rect">
+            <a:avLst/>
+          </a:prstGeom>
+          <a:noFill/>
+          <a:extLst>
+            <a:ext uri="{909E8E84-426E-40DD-AFC4-6F175D3DCCD1}">
+              <a14:hiddenFill xmlns:a14="http://schemas.microsoft.com/office/drawing/2010/main">
+                <a:solidFill>
+                  <a:srgbClr val="FFFFFF"/>
+                </a:solidFill>
+              </a14:hiddenFill>
+            </a:ext>
+          </a:extLst>
+        </p:spPr>
+      </p:pic>
+    </p:spTree>
+    <p:extLst>
+      <p:ext uri="{BB962C8B-B14F-4D97-AF65-F5344CB8AC3E}">
+        <p14:creationId xmlns:p14="http://schemas.microsoft.com/office/powerpoint/2010/main" val="2956303178"/>
+      </p:ext>
+    </p:extLst>
+  </p:cSld>
+  <p:clrMapOvr>
+    <a:masterClrMapping/>
+  </p:clrMapOvr>
+</p:sld>
+</file>
+
+<file path=ppt/slides/slide4.xml><?xml version="1.0" encoding="utf-8"?>
+<p:sld xmlns:a="http://schemas.openxmlformats.org/drawingml/2006/main" xmlns:r="http://schemas.openxmlformats.org/officeDocument/2006/relationships" xmlns:p="http://schemas.openxmlformats.org/presentationml/2006/main" show="0">
+  <p:cSld>
+    <p:spTree>
+      <p:nvGrpSpPr>
+        <p:cNvPr id="1" name="">
+          <a:extLst>
+            <a:ext uri="{FF2B5EF4-FFF2-40B4-BE49-F238E27FC236}">
+              <a16:creationId xmlns:a16="http://schemas.microsoft.com/office/drawing/2014/main" id="{000EF1D8-2233-CD60-BE05-AF588086255E}"/>
+            </a:ext>
+          </a:extLst>
+        </p:cNvPr>
+        <p:cNvGrpSpPr/>
+        <p:nvPr/>
+      </p:nvGrpSpPr>
+      <p:grpSpPr>
+        <a:xfrm>
+          <a:off x="0" y="0"/>
+          <a:ext cx="0" cy="0"/>
+          <a:chOff x="0" y="0"/>
+          <a:chExt cx="0" cy="0"/>
+        </a:xfrm>
+      </p:grpSpPr>
+      <p:sp>
+        <p:nvSpPr>
+          <p:cNvPr id="2" name="Title 1">
+            <a:extLst>
+              <a:ext uri="{FF2B5EF4-FFF2-40B4-BE49-F238E27FC236}">
+                <a16:creationId xmlns:a16="http://schemas.microsoft.com/office/drawing/2014/main" id="{0DF44936-1A98-D22C-7E5E-0308E3C013D9}"/>
+              </a:ext>
+            </a:extLst>
+          </p:cNvPr>
+          <p:cNvSpPr>
+            <a:spLocks noGrp="1"/>
+          </p:cNvSpPr>
+          <p:nvPr>
+            <p:ph type="title"/>
+          </p:nvPr>
+        </p:nvSpPr>
+        <p:spPr/>
+        <p:txBody>
+          <a:bodyPr/>
+          <a:lstStyle/>
+          <a:p>
+            <a:r>
+              <a:rPr lang="en-US" dirty="0"/>
+              <a:t>Who is Sean Whitesell?</a:t>
+            </a:r>
+          </a:p>
+        </p:txBody>
+      </p:sp>
+      <p:sp>
+        <p:nvSpPr>
+          <p:cNvPr id="4" name="Content Placeholder 2">
+            <a:extLst>
+              <a:ext uri="{FF2B5EF4-FFF2-40B4-BE49-F238E27FC236}">
+                <a16:creationId xmlns:a16="http://schemas.microsoft.com/office/drawing/2014/main" id="{4DA2EFFA-D7EA-7FC2-1006-4BD33B4EDB44}"/>
+              </a:ext>
+            </a:extLst>
+          </p:cNvPr>
+          <p:cNvSpPr txBox="1">
+            <a:spLocks/>
+          </p:cNvSpPr>
+          <p:nvPr/>
+        </p:nvSpPr>
+        <p:spPr>
+          <a:xfrm>
+            <a:off x="765175" y="1638152"/>
+            <a:ext cx="6177967" cy="3596120"/>
+          </a:xfrm>
+          <a:prstGeom prst="rect">
+            <a:avLst/>
+          </a:prstGeom>
+        </p:spPr>
+        <p:txBody>
+          <a:bodyPr>
+            <a:normAutofit/>
+          </a:bodyPr>
+          <a:lstStyle>
+            <a:lvl1pPr marL="228600" indent="-228600" algn="l" defTabSz="914400" rtl="0" eaLnBrk="1" latinLnBrk="0" hangingPunct="1">
+              <a:lnSpc>
+                <a:spcPct val="90000"/>
+              </a:lnSpc>
+              <a:spcBef>
+                <a:spcPts val="1000"/>
+              </a:spcBef>
+              <a:buFont typeface="Arial" panose="020B0604020202020204" pitchFamily="34" charset="0"/>
+              <a:buChar char="•"/>
+              <a:defRPr sz="2800" kern="1200">
+                <a:solidFill>
+                  <a:schemeClr val="bg1"/>
+                </a:solidFill>
+                <a:latin typeface="+mn-lt"/>
+                <a:ea typeface="+mn-ea"/>
+                <a:cs typeface="+mn-cs"/>
+              </a:defRPr>
+            </a:lvl1pPr>
+            <a:lvl2pPr marL="685800" indent="-228600" algn="l" defTabSz="914400" rtl="0" eaLnBrk="1" latinLnBrk="0" hangingPunct="1">
+              <a:lnSpc>
+                <a:spcPct val="90000"/>
+              </a:lnSpc>
+              <a:spcBef>
+                <a:spcPts val="500"/>
+              </a:spcBef>
+              <a:buFont typeface="Arial" panose="020B0604020202020204" pitchFamily="34" charset="0"/>
+              <a:buChar char="•"/>
+              <a:defRPr sz="2400" kern="1200">
+                <a:solidFill>
+                  <a:schemeClr val="bg1"/>
+                </a:solidFill>
+                <a:latin typeface="+mn-lt"/>
+                <a:ea typeface="+mn-ea"/>
+                <a:cs typeface="+mn-cs"/>
+              </a:defRPr>
+            </a:lvl2pPr>
+            <a:lvl3pPr marL="1143000" indent="-228600" algn="l" defTabSz="914400" rtl="0" eaLnBrk="1" latinLnBrk="0" hangingPunct="1">
+              <a:lnSpc>
+                <a:spcPct val="90000"/>
+              </a:lnSpc>
+              <a:spcBef>
+                <a:spcPts val="500"/>
+              </a:spcBef>
+              <a:buFont typeface="Arial" panose="020B0604020202020204" pitchFamily="34" charset="0"/>
+              <a:buChar char="•"/>
+              <a:defRPr sz="2000" kern="1200">
+                <a:solidFill>
+                  <a:schemeClr val="bg1"/>
+                </a:solidFill>
+                <a:latin typeface="+mn-lt"/>
+                <a:ea typeface="+mn-ea"/>
+                <a:cs typeface="+mn-cs"/>
+              </a:defRPr>
+            </a:lvl3pPr>
+            <a:lvl4pPr marL="1600200" indent="-228600" algn="l" defTabSz="914400" rtl="0" eaLnBrk="1" latinLnBrk="0" hangingPunct="1">
+              <a:lnSpc>
+                <a:spcPct val="90000"/>
+              </a:lnSpc>
+              <a:spcBef>
+                <a:spcPts val="500"/>
+              </a:spcBef>
+              <a:buFont typeface="Arial" panose="020B0604020202020204" pitchFamily="34" charset="0"/>
+              <a:buChar char="•"/>
+              <a:defRPr sz="1800" kern="1200">
+                <a:solidFill>
+                  <a:schemeClr val="bg1"/>
+                </a:solidFill>
+                <a:latin typeface="+mn-lt"/>
+                <a:ea typeface="+mn-ea"/>
+                <a:cs typeface="+mn-cs"/>
+              </a:defRPr>
+            </a:lvl4pPr>
+            <a:lvl5pPr marL="2057400" indent="-228600" algn="l" defTabSz="914400" rtl="0" eaLnBrk="1" latinLnBrk="0" hangingPunct="1">
+              <a:lnSpc>
+                <a:spcPct val="90000"/>
+              </a:lnSpc>
+              <a:spcBef>
+                <a:spcPts val="500"/>
+              </a:spcBef>
+              <a:buFont typeface="Arial" panose="020B0604020202020204" pitchFamily="34" charset="0"/>
+              <a:buChar char="•"/>
+              <a:defRPr sz="1800" kern="1200">
+                <a:solidFill>
+                  <a:schemeClr val="bg1"/>
+                </a:solidFill>
+                <a:latin typeface="+mn-lt"/>
+                <a:ea typeface="+mn-ea"/>
+                <a:cs typeface="+mn-cs"/>
+              </a:defRPr>
+            </a:lvl5pPr>
+            <a:lvl6pPr marL="2514600" indent="-228600" algn="l" defTabSz="914400" rtl="0" eaLnBrk="1" latinLnBrk="0" hangingPunct="1">
+              <a:lnSpc>
+                <a:spcPct val="90000"/>
+              </a:lnSpc>
+              <a:spcBef>
+                <a:spcPts val="500"/>
+              </a:spcBef>
+              <a:buFont typeface="Arial" panose="020B0604020202020204" pitchFamily="34" charset="0"/>
+              <a:buChar char="•"/>
+              <a:defRPr sz="1800" kern="1200">
+                <a:solidFill>
+                  <a:schemeClr val="tx1"/>
+                </a:solidFill>
+                <a:latin typeface="+mn-lt"/>
+                <a:ea typeface="+mn-ea"/>
+                <a:cs typeface="+mn-cs"/>
+              </a:defRPr>
+            </a:lvl6pPr>
+            <a:lvl7pPr marL="2971800" indent="-228600" algn="l" defTabSz="914400" rtl="0" eaLnBrk="1" latinLnBrk="0" hangingPunct="1">
+              <a:lnSpc>
+                <a:spcPct val="90000"/>
+              </a:lnSpc>
+              <a:spcBef>
+                <a:spcPts val="500"/>
+              </a:spcBef>
+              <a:buFont typeface="Arial" panose="020B0604020202020204" pitchFamily="34" charset="0"/>
+              <a:buChar char="•"/>
+              <a:defRPr sz="1800" kern="1200">
+                <a:solidFill>
+                  <a:schemeClr val="tx1"/>
+                </a:solidFill>
+                <a:latin typeface="+mn-lt"/>
+                <a:ea typeface="+mn-ea"/>
+                <a:cs typeface="+mn-cs"/>
+              </a:defRPr>
+            </a:lvl7pPr>
+            <a:lvl8pPr marL="3429000" indent="-228600" algn="l" defTabSz="914400" rtl="0" eaLnBrk="1" latinLnBrk="0" hangingPunct="1">
+              <a:lnSpc>
+                <a:spcPct val="90000"/>
+              </a:lnSpc>
+              <a:spcBef>
+                <a:spcPts val="500"/>
+              </a:spcBef>
+              <a:buFont typeface="Arial" panose="020B0604020202020204" pitchFamily="34" charset="0"/>
+              <a:buChar char="•"/>
+              <a:defRPr sz="1800" kern="1200">
+                <a:solidFill>
+                  <a:schemeClr val="tx1"/>
+                </a:solidFill>
+                <a:latin typeface="+mn-lt"/>
+                <a:ea typeface="+mn-ea"/>
+                <a:cs typeface="+mn-cs"/>
+              </a:defRPr>
+            </a:lvl8pPr>
+            <a:lvl9pPr marL="3886200" indent="-228600" algn="l" defTabSz="914400" rtl="0" eaLnBrk="1" latinLnBrk="0" hangingPunct="1">
+              <a:lnSpc>
+                <a:spcPct val="90000"/>
+              </a:lnSpc>
+              <a:spcBef>
+                <a:spcPts val="500"/>
+              </a:spcBef>
+              <a:buFont typeface="Arial" panose="020B0604020202020204" pitchFamily="34" charset="0"/>
+              <a:buChar char="•"/>
+              <a:defRPr sz="1800" kern="1200">
+                <a:solidFill>
+                  <a:schemeClr val="tx1"/>
+                </a:solidFill>
+                <a:latin typeface="+mn-lt"/>
+                <a:ea typeface="+mn-ea"/>
+                <a:cs typeface="+mn-cs"/>
+              </a:defRPr>
+            </a:lvl9pPr>
+          </a:lstStyle>
+          <a:p>
+            <a:pPr marL="0" indent="0">
+              <a:buFont typeface="Arial" panose="020B0604020202020204" pitchFamily="34" charset="0"/>
+              <a:buNone/>
+            </a:pPr>
+            <a:r>
+              <a:rPr lang="en-US" sz="4000" dirty="0">
+                <a:solidFill>
+                  <a:schemeClr val="tx1"/>
+                </a:solidFill>
+              </a:rPr>
+              <a:t>chadgreen@chadgreen.com</a:t>
+            </a:r>
+          </a:p>
+          <a:p>
+            <a:pPr marL="0" indent="0">
+              <a:buFont typeface="Arial" panose="020B0604020202020204" pitchFamily="34" charset="0"/>
+              <a:buNone/>
+            </a:pPr>
+            <a:r>
+              <a:rPr lang="en-US" sz="4000" dirty="0">
+                <a:solidFill>
+                  <a:schemeClr val="tx1"/>
+                </a:solidFill>
+              </a:rPr>
+              <a:t>TaleLearnCode</a:t>
+            </a:r>
+          </a:p>
+          <a:p>
+            <a:pPr marL="0" indent="0">
+              <a:buFont typeface="Arial" panose="020B0604020202020204" pitchFamily="34" charset="0"/>
+              <a:buNone/>
+            </a:pPr>
+            <a:r>
+              <a:rPr lang="en-US" sz="4000" dirty="0">
+                <a:solidFill>
+                  <a:schemeClr val="tx1"/>
+                </a:solidFill>
+              </a:rPr>
+              <a:t>ChadGreen.com</a:t>
+            </a:r>
+          </a:p>
+          <a:p>
+            <a:pPr marL="0" indent="0">
+              <a:buFont typeface="Arial" panose="020B0604020202020204" pitchFamily="34" charset="0"/>
+              <a:buNone/>
+            </a:pPr>
+            <a:r>
+              <a:rPr lang="en-US" sz="4000" dirty="0" err="1">
+                <a:solidFill>
+                  <a:schemeClr val="tx1"/>
+                </a:solidFill>
+              </a:rPr>
+              <a:t>ChadGreen</a:t>
+            </a:r>
+            <a:r>
+              <a:rPr lang="en-US" sz="4000" dirty="0">
+                <a:solidFill>
+                  <a:schemeClr val="tx1"/>
+                </a:solidFill>
+              </a:rPr>
+              <a:t> &amp; TaleLearnCode</a:t>
+            </a:r>
+          </a:p>
+          <a:p>
+            <a:pPr marL="0" indent="0">
+              <a:buFont typeface="Arial" panose="020B0604020202020204" pitchFamily="34" charset="0"/>
+              <a:buNone/>
+            </a:pPr>
+            <a:r>
+              <a:rPr lang="en-US" sz="4000" dirty="0" err="1">
+                <a:solidFill>
+                  <a:schemeClr val="tx1"/>
+                </a:solidFill>
+              </a:rPr>
+              <a:t>ChadwickEGreen</a:t>
+            </a:r>
+            <a:endParaRPr lang="en-US" sz="4000" dirty="0">
+              <a:solidFill>
+                <a:schemeClr val="tx1"/>
+              </a:solidFill>
+            </a:endParaRPr>
+          </a:p>
+        </p:txBody>
+      </p:sp>
+      <p:pic>
+        <p:nvPicPr>
+          <p:cNvPr id="5" name="Picture 4">
+            <a:extLst>
+              <a:ext uri="{FF2B5EF4-FFF2-40B4-BE49-F238E27FC236}">
+                <a16:creationId xmlns:a16="http://schemas.microsoft.com/office/drawing/2014/main" id="{3C9BD3EA-6A98-B4AB-E848-2EA36B7CEE6E}"/>
+              </a:ext>
+            </a:extLst>
+          </p:cNvPr>
+          <p:cNvPicPr>
+            <a:picLocks noChangeAspect="1"/>
+          </p:cNvPicPr>
+          <p:nvPr/>
+        </p:nvPicPr>
+        <p:blipFill>
+          <a:blip r:embed="rId2" cstate="email">
+            <a:extLst>
+              <a:ext uri="{28A0092B-C50C-407E-A947-70E740481C1C}">
+                <a14:useLocalDpi xmlns:a14="http://schemas.microsoft.com/office/drawing/2010/main"/>
+              </a:ext>
+            </a:extLst>
+          </a:blip>
+          <a:stretch>
+            <a:fillRect/>
+          </a:stretch>
+        </p:blipFill>
+        <p:spPr>
+          <a:xfrm>
+            <a:off x="275197" y="1776928"/>
+            <a:ext cx="489978" cy="450483"/>
+          </a:xfrm>
+          <a:prstGeom prst="rect">
+            <a:avLst/>
+          </a:prstGeom>
+        </p:spPr>
+      </p:pic>
+      <p:pic>
+        <p:nvPicPr>
+          <p:cNvPr id="6" name="Picture 5">
+            <a:extLst>
+              <a:ext uri="{FF2B5EF4-FFF2-40B4-BE49-F238E27FC236}">
+                <a16:creationId xmlns:a16="http://schemas.microsoft.com/office/drawing/2014/main" id="{74895C02-EE73-072F-6AAE-89C5EDF5CF2D}"/>
+              </a:ext>
+            </a:extLst>
+          </p:cNvPr>
+          <p:cNvPicPr>
+            <a:picLocks noChangeAspect="1"/>
+          </p:cNvPicPr>
+          <p:nvPr/>
+        </p:nvPicPr>
+        <p:blipFill>
+          <a:blip r:embed="rId3" cstate="email">
+            <a:extLst>
+              <a:ext uri="{28A0092B-C50C-407E-A947-70E740481C1C}">
+                <a14:useLocalDpi xmlns:a14="http://schemas.microsoft.com/office/drawing/2010/main"/>
+              </a:ext>
+            </a:extLst>
+          </a:blip>
+          <a:stretch>
+            <a:fillRect/>
+          </a:stretch>
+        </p:blipFill>
+        <p:spPr>
+          <a:xfrm>
+            <a:off x="261786" y="2435063"/>
+            <a:ext cx="480742" cy="480742"/>
+          </a:xfrm>
+          <a:prstGeom prst="rect">
+            <a:avLst/>
+          </a:prstGeom>
+        </p:spPr>
+      </p:pic>
+      <p:pic>
+        <p:nvPicPr>
+          <p:cNvPr id="7" name="Picture 6">
+            <a:extLst>
+              <a:ext uri="{FF2B5EF4-FFF2-40B4-BE49-F238E27FC236}">
+                <a16:creationId xmlns:a16="http://schemas.microsoft.com/office/drawing/2014/main" id="{36107A88-3023-01E6-86E0-63011FB29C8A}"/>
+              </a:ext>
+            </a:extLst>
+          </p:cNvPr>
+          <p:cNvPicPr>
+            <a:picLocks noChangeAspect="1"/>
+          </p:cNvPicPr>
+          <p:nvPr/>
+        </p:nvPicPr>
+        <p:blipFill>
+          <a:blip r:embed="rId4" cstate="email">
+            <a:extLst>
+              <a:ext uri="{28A0092B-C50C-407E-A947-70E740481C1C}">
+                <a14:useLocalDpi xmlns:a14="http://schemas.microsoft.com/office/drawing/2010/main"/>
+              </a:ext>
+            </a:extLst>
+          </a:blip>
+          <a:stretch>
+            <a:fillRect/>
+          </a:stretch>
+        </p:blipFill>
+        <p:spPr>
+          <a:xfrm>
+            <a:off x="261786" y="3011339"/>
+            <a:ext cx="489978" cy="489978"/>
+          </a:xfrm>
+          <a:prstGeom prst="rect">
+            <a:avLst/>
+          </a:prstGeom>
+          <a:ln>
+            <a:noFill/>
+          </a:ln>
+        </p:spPr>
+      </p:pic>
+      <p:pic>
+        <p:nvPicPr>
+          <p:cNvPr id="8" name="Picture 7">
+            <a:extLst>
+              <a:ext uri="{FF2B5EF4-FFF2-40B4-BE49-F238E27FC236}">
+                <a16:creationId xmlns:a16="http://schemas.microsoft.com/office/drawing/2014/main" id="{86166DD7-B9CF-7F5B-97C9-3912A92FE9E9}"/>
+              </a:ext>
+            </a:extLst>
+          </p:cNvPr>
+          <p:cNvPicPr>
+            <a:picLocks noChangeAspect="1"/>
+          </p:cNvPicPr>
+          <p:nvPr/>
+        </p:nvPicPr>
+        <p:blipFill>
+          <a:blip r:embed="rId5" cstate="email">
+            <a:extLst>
+              <a:ext uri="{28A0092B-C50C-407E-A947-70E740481C1C}">
+                <a14:useLocalDpi xmlns:a14="http://schemas.microsoft.com/office/drawing/2010/main"/>
+              </a:ext>
+            </a:extLst>
+          </a:blip>
+          <a:stretch>
+            <a:fillRect/>
+          </a:stretch>
+        </p:blipFill>
+        <p:spPr>
+          <a:xfrm>
+            <a:off x="261786" y="3727672"/>
+            <a:ext cx="480742" cy="480742"/>
+          </a:xfrm>
+          <a:prstGeom prst="rect">
+            <a:avLst/>
+          </a:prstGeom>
+        </p:spPr>
+      </p:pic>
+      <p:pic>
+        <p:nvPicPr>
+          <p:cNvPr id="9" name="Picture 8">
+            <a:extLst>
+              <a:ext uri="{FF2B5EF4-FFF2-40B4-BE49-F238E27FC236}">
+                <a16:creationId xmlns:a16="http://schemas.microsoft.com/office/drawing/2014/main" id="{17FCDC29-D0DC-626A-541B-335DD9D88F23}"/>
+              </a:ext>
+            </a:extLst>
+          </p:cNvPr>
+          <p:cNvPicPr>
+            <a:picLocks noChangeAspect="1"/>
+          </p:cNvPicPr>
+          <p:nvPr/>
+        </p:nvPicPr>
+        <p:blipFill>
+          <a:blip r:embed="rId6" cstate="email">
+            <a:extLst>
+              <a:ext uri="{28A0092B-C50C-407E-A947-70E740481C1C}">
+                <a14:useLocalDpi xmlns:a14="http://schemas.microsoft.com/office/drawing/2010/main"/>
+              </a:ext>
+            </a:extLst>
+          </a:blip>
+          <a:stretch>
+            <a:fillRect/>
+          </a:stretch>
+        </p:blipFill>
+        <p:spPr>
+          <a:xfrm>
+            <a:off x="274711" y="4365792"/>
+            <a:ext cx="445655" cy="445655"/>
+          </a:xfrm>
+          <a:prstGeom prst="rect">
+            <a:avLst/>
+          </a:prstGeom>
+        </p:spPr>
+      </p:pic>
+      <p:pic>
+        <p:nvPicPr>
+          <p:cNvPr id="10" name="Picture 9">
+            <a:extLst>
+              <a:ext uri="{FF2B5EF4-FFF2-40B4-BE49-F238E27FC236}">
+                <a16:creationId xmlns:a16="http://schemas.microsoft.com/office/drawing/2014/main" id="{F9894C5B-B0C7-4DBA-1937-E73BBAEBBDF1}"/>
+              </a:ext>
+            </a:extLst>
+          </p:cNvPr>
+          <p:cNvPicPr>
+            <a:picLocks noChangeAspect="1"/>
+          </p:cNvPicPr>
+          <p:nvPr/>
+        </p:nvPicPr>
+        <p:blipFill>
+          <a:blip r:embed="rId7" cstate="email">
+            <a:extLst>
+              <a:ext uri="{28A0092B-C50C-407E-A947-70E740481C1C}">
+                <a14:useLocalDpi xmlns:a14="http://schemas.microsoft.com/office/drawing/2010/main"/>
+              </a:ext>
+            </a:extLst>
+          </a:blip>
+          <a:stretch>
+            <a:fillRect/>
+          </a:stretch>
+        </p:blipFill>
+        <p:spPr>
+          <a:xfrm>
+            <a:off x="472151" y="5171221"/>
+            <a:ext cx="2289053" cy="923546"/>
+          </a:xfrm>
+          <a:prstGeom prst="rect">
+            <a:avLst/>
+          </a:prstGeom>
+        </p:spPr>
+      </p:pic>
+      <p:pic>
+        <p:nvPicPr>
+          <p:cNvPr id="1026" name="Picture 2" descr="Profile photo of Sean Whitesell">
+            <a:extLst>
+              <a:ext uri="{FF2B5EF4-FFF2-40B4-BE49-F238E27FC236}">
+                <a16:creationId xmlns:a16="http://schemas.microsoft.com/office/drawing/2014/main" id="{9DE5019C-6B44-1E50-95DC-49BA04152FC9}"/>
+              </a:ext>
+            </a:extLst>
+          </p:cNvPr>
+          <p:cNvPicPr>
+            <a:picLocks noChangeAspect="1" noChangeArrowheads="1"/>
+          </p:cNvPicPr>
+          <p:nvPr/>
+        </p:nvPicPr>
+        <p:blipFill rotWithShape="1">
+          <a:blip r:embed="rId8">
+            <a:extLst>
+              <a:ext uri="{28A0092B-C50C-407E-A947-70E740481C1C}">
+                <a14:useLocalDpi xmlns:a14="http://schemas.microsoft.com/office/drawing/2010/main" val="0"/>
+              </a:ext>
+            </a:extLst>
+          </a:blip>
+          <a:srcRect l="19502" r="19502"/>
+          <a:stretch>
+            <a:fillRect/>
+          </a:stretch>
+        </p:blipFill>
+        <p:spPr bwMode="auto">
+          <a:xfrm>
+            <a:off x="8008882" y="0"/>
+            <a:ext cx="4183117" cy="6858000"/>
+          </a:xfrm>
+          <a:prstGeom prst="rect">
+            <a:avLst/>
+          </a:prstGeom>
+          <a:noFill/>
+          <a:extLst>
+            <a:ext uri="{909E8E84-426E-40DD-AFC4-6F175D3DCCD1}">
+              <a14:hiddenFill xmlns:a14="http://schemas.microsoft.com/office/drawing/2010/main">
+                <a:solidFill>
+                  <a:srgbClr val="FFFFFF"/>
+                </a:solidFill>
+              </a14:hiddenFill>
+            </a:ext>
+          </a:extLst>
+        </p:spPr>
+      </p:pic>
+    </p:spTree>
+    <p:extLst>
+      <p:ext uri="{BB962C8B-B14F-4D97-AF65-F5344CB8AC3E}">
+        <p14:creationId xmlns:p14="http://schemas.microsoft.com/office/powerpoint/2010/main" val="1721514873"/>
+      </p:ext>
+    </p:extLst>
+  </p:cSld>
+  <p:clrMapOvr>
+    <a:masterClrMapping/>
+  </p:clrMapOvr>
+</p:sld>
+</file>
+
+<file path=ppt/slides/slide5.xml><?xml version="1.0" encoding="utf-8"?>
+<p:sld xmlns:a="http://schemas.openxmlformats.org/drawingml/2006/main" xmlns:r="http://schemas.openxmlformats.org/officeDocument/2006/relationships" xmlns:p="http://schemas.openxmlformats.org/presentationml/2006/main">
+  <p:cSld>
+    <p:spTree>
+      <p:nvGrpSpPr>
         <p:cNvPr id="1" name=""/>
         <p:cNvGrpSpPr/>
         <p:nvPr/>
@@ -3954,7 +4739,7 @@
             </a:pPr>
             <a:r>
               <a:rPr lang="en-US" dirty="0"/>
-              <a:t>11:25 – Quick Pool &amp; Pre-Lunch Wrap</a:t>
+              <a:t>11:25 – Quick Poll &amp; Pre-Lunch Wrap</a:t>
             </a:r>
           </a:p>
           <a:p>
@@ -4041,7 +4826,7 @@
 </p:sld>
 </file>
 
-<file path=ppt/slides/slide4.xml><?xml version="1.0" encoding="utf-8"?>
+<file path=ppt/slides/slide6.xml><?xml version="1.0" encoding="utf-8"?>
 <p:sld xmlns:a="http://schemas.openxmlformats.org/drawingml/2006/main" xmlns:r="http://schemas.openxmlformats.org/officeDocument/2006/relationships" xmlns:p="http://schemas.openxmlformats.org/presentationml/2006/main">
   <p:cSld>
     <p:spTree>

</xml_diff>